<commit_message>
small changes/fixes in PPT
</commit_message>
<xml_diff>
--- a/08_09/09_eloadas_Angular_HTTP_kommunikacio.pptx
+++ b/08_09/09_eloadas_Angular_HTTP_kommunikacio.pptx
@@ -207,7 +207,7 @@
           <a:p>
             <a:fld id="{4C482E4E-5CEC-44A9-BF2B-512FB3B5604F}" type="datetimeFigureOut">
               <a:rPr lang="en-US" smtClean="0"/>
-              <a:t>1/18/2026</a:t>
+              <a:t>4/11/2026</a:t>
             </a:fld>
             <a:endParaRPr lang="en-US"/>
           </a:p>
@@ -6173,15 +6173,15 @@
             </a:r>
             <a:r>
               <a:rPr lang="hu-HU" dirty="0"/>
-              <a:t>, átalakíthatja felhasználó barát </a:t>
-            </a:r>
-            <a:r>
-              <a:rPr lang="hu-HU" dirty="0" err="1"/>
-              <a:t>formátumb</a:t>
+              <a:t>, átalakíthatja felhasználó </a:t>
+            </a:r>
+            <a:r>
+              <a:rPr lang="hu-HU"/>
+              <a:t>barát formátumba, </a:t>
             </a:r>
             <a:r>
               <a:rPr lang="hu-HU" dirty="0"/>
-              <a:t>, stb. A komponens csak reagál, és megjeleníti a hibaüzenetet. </a:t>
+              <a:t>stb. A komponens csak reagál, és megjeleníti a hibaüzenetet. </a:t>
             </a:r>
             <a:r>
               <a:rPr lang="en-US" dirty="0"/>
@@ -6971,7 +6971,7 @@
           <a:p>
             <a:fld id="{E80C50CD-E178-4744-9B35-B2F624D6C5E9}" type="datetimeFigureOut">
               <a:rPr lang="en-US" smtClean="0"/>
-              <a:t>1/18/2026</a:t>
+              <a:t>4/11/2026</a:t>
             </a:fld>
             <a:endParaRPr lang="en-US"/>
           </a:p>
@@ -7169,7 +7169,7 @@
           <a:p>
             <a:fld id="{E80C50CD-E178-4744-9B35-B2F624D6C5E9}" type="datetimeFigureOut">
               <a:rPr lang="en-US" smtClean="0"/>
-              <a:t>1/18/2026</a:t>
+              <a:t>4/11/2026</a:t>
             </a:fld>
             <a:endParaRPr lang="en-US"/>
           </a:p>
@@ -7377,7 +7377,7 @@
           <a:p>
             <a:fld id="{E80C50CD-E178-4744-9B35-B2F624D6C5E9}" type="datetimeFigureOut">
               <a:rPr lang="en-US" smtClean="0"/>
-              <a:t>1/18/2026</a:t>
+              <a:t>4/11/2026</a:t>
             </a:fld>
             <a:endParaRPr lang="en-US"/>
           </a:p>
@@ -7627,7 +7627,7 @@
           <a:p>
             <a:fld id="{E80C50CD-E178-4744-9B35-B2F624D6C5E9}" type="datetimeFigureOut">
               <a:rPr lang="en-US" smtClean="0"/>
-              <a:t>1/18/2026</a:t>
+              <a:t>4/11/2026</a:t>
             </a:fld>
             <a:endParaRPr lang="en-US"/>
           </a:p>
@@ -7906,7 +7906,7 @@
           <a:p>
             <a:fld id="{E80C50CD-E178-4744-9B35-B2F624D6C5E9}" type="datetimeFigureOut">
               <a:rPr lang="en-US" smtClean="0"/>
-              <a:t>1/18/2026</a:t>
+              <a:t>4/11/2026</a:t>
             </a:fld>
             <a:endParaRPr lang="en-US"/>
           </a:p>
@@ -8223,7 +8223,7 @@
           <a:p>
             <a:fld id="{E80C50CD-E178-4744-9B35-B2F624D6C5E9}" type="datetimeFigureOut">
               <a:rPr lang="en-US" smtClean="0"/>
-              <a:t>1/18/2026</a:t>
+              <a:t>4/11/2026</a:t>
             </a:fld>
             <a:endParaRPr lang="en-US"/>
           </a:p>
@@ -8639,7 +8639,7 @@
           <a:p>
             <a:fld id="{E80C50CD-E178-4744-9B35-B2F624D6C5E9}" type="datetimeFigureOut">
               <a:rPr lang="en-US" smtClean="0"/>
-              <a:t>1/18/2026</a:t>
+              <a:t>4/11/2026</a:t>
             </a:fld>
             <a:endParaRPr lang="en-US"/>
           </a:p>
@@ -8780,7 +8780,7 @@
           <a:p>
             <a:fld id="{E80C50CD-E178-4744-9B35-B2F624D6C5E9}" type="datetimeFigureOut">
               <a:rPr lang="en-US" smtClean="0"/>
-              <a:t>1/18/2026</a:t>
+              <a:t>4/11/2026</a:t>
             </a:fld>
             <a:endParaRPr lang="en-US"/>
           </a:p>
@@ -8893,7 +8893,7 @@
           <a:p>
             <a:fld id="{E80C50CD-E178-4744-9B35-B2F624D6C5E9}" type="datetimeFigureOut">
               <a:rPr lang="en-US" smtClean="0"/>
-              <a:t>1/18/2026</a:t>
+              <a:t>4/11/2026</a:t>
             </a:fld>
             <a:endParaRPr lang="en-US"/>
           </a:p>
@@ -9210,7 +9210,7 @@
           <a:p>
             <a:fld id="{E80C50CD-E178-4744-9B35-B2F624D6C5E9}" type="datetimeFigureOut">
               <a:rPr lang="en-US" smtClean="0"/>
-              <a:t>1/18/2026</a:t>
+              <a:t>4/11/2026</a:t>
             </a:fld>
             <a:endParaRPr lang="en-US"/>
           </a:p>
@@ -9502,7 +9502,7 @@
           <a:p>
             <a:fld id="{E80C50CD-E178-4744-9B35-B2F624D6C5E9}" type="datetimeFigureOut">
               <a:rPr lang="en-US" smtClean="0"/>
-              <a:t>1/18/2026</a:t>
+              <a:t>4/11/2026</a:t>
             </a:fld>
             <a:endParaRPr lang="en-US"/>
           </a:p>
@@ -9742,7 +9742,7 @@
             <a:fld id="{E80C50CD-E178-4744-9B35-B2F624D6C5E9}" type="datetimeFigureOut">
               <a:rPr lang="en-US" smtClean="0"/>
               <a:pPr/>
-              <a:t>1/18/2026</a:t>
+              <a:t>4/11/2026</a:t>
             </a:fld>
             <a:endParaRPr lang="en-US"/>
           </a:p>

</xml_diff>